<commit_message>
sd-11-004: qualify the hot-site data-loss claim in lesson, deck and PPTX
Co-Authored-By: Claude Sonnet 5.5 <noreply@anthropic.com>
Claude-Session: https://claude.ai/code/session_0121Z35eF2EmPsW9asDgHWsZ
</commit_message>
<xml_diff>
--- a/system-design-101/vi/lessons/sd-11-004/slides/sd-11-004.pptx
+++ b/system-design-101/vi/lessons/sd-11-004/slides/sd-11-004.pptx
@@ -10096,7 +10096,7 @@
       </p:sp>
       <p:sp>
         <p:nvSpPr>
-          <p:cNvPr id="7" name="Text richtext-1792420735388-662704508"/>
+          <p:cNvPr id="7" name="Text 5"/>
           <p:cNvSpPr/>
           <p:nvPr/>
         </p:nvSpPr>
@@ -10115,13 +10115,11 @@
           <a:bodyPr wrap="square" lIns="0" tIns="0" rIns="0" bIns="0" rtlCol="0" anchor="ctr"/>
           <a:lstStyle/>
           <a:p>
-            <a:pPr algn="l" marL="323850" indent="-231371">
+            <a:pPr algn="l" indent="0" marL="0">
               <a:spcAft>
                 <a:spcPts val="1050"/>
               </a:spcAft>
-              <a:buSzPct val="100000"/>
-              <a:buFont typeface="Arial"/>
-              <a:buChar char="•"/>
+              <a:buNone/>
             </a:pPr>
             <a:r>
               <a:rPr lang="en-US" sz="2550" dirty="0" spc="-1" kern="0">
@@ -10165,7 +10163,73 @@
                 <a:ea typeface="Be Vietnam Pro" pitchFamily="34" charset="-122"/>
                 <a:cs typeface="Be Vietnam Pro" pitchFamily="34" charset="-120"/>
               </a:rPr>
-              <a:t> ngừng,</a:t>
+              <a:t> ngừng;</a:t>
+            </a:r>
+            <a:r>
+              <a:rPr lang="en-US" sz="2550" dirty="0" spc="-11" kern="0">
+                <a:solidFill>
+                  <a:srgbClr val="E4E1D8"/>
+                </a:solidFill>
+                <a:latin typeface="Be Vietnam Pro" pitchFamily="34" charset="0"/>
+                <a:ea typeface="Be Vietnam Pro" pitchFamily="34" charset="-122"/>
+                <a:cs typeface="Be Vietnam Pro" pitchFamily="34" charset="-120"/>
+              </a:rPr>
+              <a:t> mất</a:t>
+            </a:r>
+            <a:r>
+              <a:rPr lang="en-US" sz="2550" dirty="0" spc="-3" kern="0">
+                <a:solidFill>
+                  <a:srgbClr val="E4E1D8"/>
+                </a:solidFill>
+                <a:latin typeface="Be Vietnam Pro" pitchFamily="34" charset="0"/>
+                <a:ea typeface="Be Vietnam Pro" pitchFamily="34" charset="-122"/>
+                <a:cs typeface="Be Vietnam Pro" pitchFamily="34" charset="-120"/>
+              </a:rPr>
+              <a:t> dữ</a:t>
+            </a:r>
+            <a:r>
+              <a:rPr lang="en-US" sz="2550" dirty="0" spc="2" kern="0">
+                <a:solidFill>
+                  <a:srgbClr val="E4E1D8"/>
+                </a:solidFill>
+                <a:latin typeface="Be Vietnam Pro" pitchFamily="34" charset="0"/>
+                <a:ea typeface="Be Vietnam Pro" pitchFamily="34" charset="-122"/>
+                <a:cs typeface="Be Vietnam Pro" pitchFamily="34" charset="-120"/>
+              </a:rPr>
+              <a:t> liệu</a:t>
+            </a:r>
+            <a:r>
+              <a:rPr lang="en-US" sz="2550" dirty="0" spc="-38" kern="0">
+                <a:solidFill>
+                  <a:srgbClr val="E4E1D8"/>
+                </a:solidFill>
+                <a:latin typeface="Be Vietnam Pro" pitchFamily="34" charset="0"/>
+                <a:ea typeface="Be Vietnam Pro" pitchFamily="34" charset="-122"/>
+                <a:cs typeface="Be Vietnam Pro" pitchFamily="34" charset="-120"/>
+              </a:rPr>
+              <a:t> rất</a:t>
+            </a:r>
+            <a:r>
+              <a:rPr lang="en-US" sz="2550" dirty="0" spc="2" kern="0">
+                <a:solidFill>
+                  <a:srgbClr val="E4E1D8"/>
+                </a:solidFill>
+                <a:latin typeface="Be Vietnam Pro" pitchFamily="34" charset="0"/>
+                <a:ea typeface="Be Vietnam Pro" pitchFamily="34" charset="-122"/>
+                <a:cs typeface="Be Vietnam Pro" pitchFamily="34" charset="-120"/>
+              </a:rPr>
+              <a:t> ít,</a:t>
+            </a:r>
+            <a:r>
+              <a:rPr lang="en-US" sz="2550" dirty="0" spc="6" kern="0">
+                <a:solidFill>
+                  <a:srgbClr val="E4E1D8"/>
+                </a:solidFill>
+                <a:latin typeface="Be Vietnam Pro" pitchFamily="34" charset="0"/>
+                <a:ea typeface="Be Vietnam Pro" pitchFamily="34" charset="-122"/>
+                <a:cs typeface="Be Vietnam Pro" pitchFamily="34" charset="-120"/>
+              </a:rPr>
+              <a:t> chưa</a:t>
             </a:r>
             <a:r>
               <a:rPr lang="en-US" sz="2550" dirty="0" spc="0" kern="0">
@@ -10176,10 +10240,10 @@
                 <a:ea typeface="Be Vietnam Pro" pitchFamily="34" charset="-122"/>
                 <a:cs typeface="Be Vietnam Pro" pitchFamily="34" charset="-120"/>
               </a:rPr>
-              <a:t> không</a:t>
-            </a:r>
-            <a:r>
-              <a:rPr lang="en-US" sz="2550" dirty="0" spc="-11" kern="0">
+              <a:t> chắc</a:t>
+            </a:r>
+            <a:r>
+              <a:rPr lang="en-US" sz="2550" dirty="0" spc="-2" kern="0">
                 <a:solidFill>
                   <a:srgbClr val="E4E1D8"/>
                 </a:solidFill>
@@ -10187,10 +10251,10 @@
                 <a:ea typeface="Be Vietnam Pro" pitchFamily="34" charset="-122"/>
                 <a:cs typeface="Be Vietnam Pro" pitchFamily="34" charset="-120"/>
               </a:rPr>
-              <a:t> mất</a:t>
-            </a:r>
-            <a:r>
-              <a:rPr lang="en-US" sz="2550" dirty="0" spc="-2" kern="0">
+              <a:t> bằng</a:t>
+            </a:r>
+            <a:r>
+              <a:rPr lang="en-US" sz="2550" dirty="0" spc="-1" kern="0">
                 <a:solidFill>
                   <a:srgbClr val="E4E1D8"/>
                 </a:solidFill>
@@ -10198,26 +10262,13 @@
                 <a:ea typeface="Be Vietnam Pro" pitchFamily="34" charset="-122"/>
                 <a:cs typeface="Be Vietnam Pro" pitchFamily="34" charset="-120"/>
               </a:rPr>
-              <a:t> dữ</a:t>
-            </a:r>
-            <a:r>
-              <a:rPr lang="en-US" sz="2550" dirty="0" spc="1" kern="0">
-                <a:solidFill>
-                  <a:srgbClr val="E4E1D8"/>
-                </a:solidFill>
-                <a:latin typeface="Be Vietnam Pro" pitchFamily="34" charset="0"/>
-                <a:ea typeface="Be Vietnam Pro" pitchFamily="34" charset="-122"/>
-                <a:cs typeface="Be Vietnam Pro" pitchFamily="34" charset="-120"/>
-              </a:rPr>
-              <a:t> liệu</a:t>
+              <a:t> 0</a:t>
             </a:r>
             <a:endParaRPr lang="en-US" sz="2550" dirty="0"/>
           </a:p>
           <a:p>
-            <a:pPr algn="l" marL="323850" indent="-231371">
-              <a:buSzPct val="100000"/>
-              <a:buFont typeface="Arial"/>
-              <a:buChar char="•"/>
+            <a:pPr algn="l" indent="0" marL="0">
+              <a:buNone/>
             </a:pPr>
             <a:r>
               <a:rPr lang="en-US" sz="2550" dirty="0" spc="-16" kern="0">

</xml_diff>